<commit_message>
docs: update group project report for LTDPT mobile application
</commit_message>
<xml_diff>
--- a/BaoCao_NhomChanLinhNguLam.pptx
+++ b/BaoCao_NhomChanLinhNguLam.pptx
@@ -767,7 +767,7 @@
           <a:p>
             <a:fld id="{5BCAD085-E8A6-8845-BD4E-CB4CCA059FC4}" type="datetimeFigureOut">
               <a:rPr lang="en-US" smtClean="0"/>
-              <a:t>7/16/2026</a:t>
+              <a:t>7/17/2026</a:t>
             </a:fld>
             <a:endParaRPr lang="en-US"/>
           </a:p>
@@ -935,7 +935,7 @@
           <a:p>
             <a:fld id="{5BCAD085-E8A6-8845-BD4E-CB4CCA059FC4}" type="datetimeFigureOut">
               <a:rPr lang="en-US" smtClean="0"/>
-              <a:t>7/16/2026</a:t>
+              <a:t>7/17/2026</a:t>
             </a:fld>
             <a:endParaRPr lang="en-US"/>
           </a:p>
@@ -1113,7 +1113,7 @@
           <a:p>
             <a:fld id="{5BCAD085-E8A6-8845-BD4E-CB4CCA059FC4}" type="datetimeFigureOut">
               <a:rPr lang="en-US" smtClean="0"/>
-              <a:t>7/16/2026</a:t>
+              <a:t>7/17/2026</a:t>
             </a:fld>
             <a:endParaRPr lang="en-US"/>
           </a:p>
@@ -1281,7 +1281,7 @@
           <a:p>
             <a:fld id="{5BCAD085-E8A6-8845-BD4E-CB4CCA059FC4}" type="datetimeFigureOut">
               <a:rPr lang="en-US" smtClean="0"/>
-              <a:t>7/16/2026</a:t>
+              <a:t>7/17/2026</a:t>
             </a:fld>
             <a:endParaRPr lang="en-US"/>
           </a:p>
@@ -1526,7 +1526,7 @@
           <a:p>
             <a:fld id="{5BCAD085-E8A6-8845-BD4E-CB4CCA059FC4}" type="datetimeFigureOut">
               <a:rPr lang="en-US" smtClean="0"/>
-              <a:t>7/16/2026</a:t>
+              <a:t>7/17/2026</a:t>
             </a:fld>
             <a:endParaRPr lang="en-US"/>
           </a:p>
@@ -1811,7 +1811,7 @@
           <a:p>
             <a:fld id="{5BCAD085-E8A6-8845-BD4E-CB4CCA059FC4}" type="datetimeFigureOut">
               <a:rPr lang="en-US" smtClean="0"/>
-              <a:t>7/16/2026</a:t>
+              <a:t>7/17/2026</a:t>
             </a:fld>
             <a:endParaRPr lang="en-US"/>
           </a:p>
@@ -2230,7 +2230,7 @@
           <a:p>
             <a:fld id="{5BCAD085-E8A6-8845-BD4E-CB4CCA059FC4}" type="datetimeFigureOut">
               <a:rPr lang="en-US" smtClean="0"/>
-              <a:t>7/16/2026</a:t>
+              <a:t>7/17/2026</a:t>
             </a:fld>
             <a:endParaRPr lang="en-US"/>
           </a:p>
@@ -2347,7 +2347,7 @@
           <a:p>
             <a:fld id="{5BCAD085-E8A6-8845-BD4E-CB4CCA059FC4}" type="datetimeFigureOut">
               <a:rPr lang="en-US" smtClean="0"/>
-              <a:t>7/16/2026</a:t>
+              <a:t>7/17/2026</a:t>
             </a:fld>
             <a:endParaRPr lang="en-US"/>
           </a:p>
@@ -2442,7 +2442,7 @@
           <a:p>
             <a:fld id="{5BCAD085-E8A6-8845-BD4E-CB4CCA059FC4}" type="datetimeFigureOut">
               <a:rPr lang="en-US" smtClean="0"/>
-              <a:t>7/16/2026</a:t>
+              <a:t>7/17/2026</a:t>
             </a:fld>
             <a:endParaRPr lang="en-US"/>
           </a:p>
@@ -2717,7 +2717,7 @@
           <a:p>
             <a:fld id="{5BCAD085-E8A6-8845-BD4E-CB4CCA059FC4}" type="datetimeFigureOut">
               <a:rPr lang="en-US" smtClean="0"/>
-              <a:t>7/16/2026</a:t>
+              <a:t>7/17/2026</a:t>
             </a:fld>
             <a:endParaRPr lang="en-US"/>
           </a:p>
@@ -2969,7 +2969,7 @@
           <a:p>
             <a:fld id="{5BCAD085-E8A6-8845-BD4E-CB4CCA059FC4}" type="datetimeFigureOut">
               <a:rPr lang="en-US" smtClean="0"/>
-              <a:t>7/16/2026</a:t>
+              <a:t>7/17/2026</a:t>
             </a:fld>
             <a:endParaRPr lang="en-US"/>
           </a:p>
@@ -3180,7 +3180,7 @@
           <a:p>
             <a:fld id="{5BCAD085-E8A6-8845-BD4E-CB4CCA059FC4}" type="datetimeFigureOut">
               <a:rPr lang="en-US" smtClean="0"/>
-              <a:t>7/16/2026</a:t>
+              <a:t>7/17/2026</a:t>
             </a:fld>
             <a:endParaRPr lang="en-US"/>
           </a:p>
@@ -3801,6 +3801,13 @@
   <p:clrMapOvr>
     <a:masterClrMapping/>
   </p:clrMapOvr>
+  <p:timing>
+    <p:tnLst>
+      <p:par>
+        <p:cTn id="1" dur="indefinite" restart="never" nodeType="tmRoot"/>
+      </p:par>
+    </p:tnLst>
+  </p:timing>
 </p:sld>
 </file>
 
@@ -5347,6 +5354,13 @@
   <p:clrMapOvr>
     <a:masterClrMapping/>
   </p:clrMapOvr>
+  <p:timing>
+    <p:tnLst>
+      <p:par>
+        <p:cTn id="1" dur="indefinite" restart="never" nodeType="tmRoot"/>
+      </p:par>
+    </p:tnLst>
+  </p:timing>
 </p:sld>
 </file>
 
@@ -7773,6 +7787,13 @@
   <p:clrMapOvr>
     <a:masterClrMapping/>
   </p:clrMapOvr>
+  <p:timing>
+    <p:tnLst>
+      <p:par>
+        <p:cTn id="1" dur="indefinite" restart="never" nodeType="tmRoot"/>
+      </p:par>
+    </p:tnLst>
+  </p:timing>
 </p:sld>
 </file>
 
@@ -9610,6 +9631,13 @@
   <p:clrMapOvr>
     <a:masterClrMapping/>
   </p:clrMapOvr>
+  <p:timing>
+    <p:tnLst>
+      <p:par>
+        <p:cTn id="1" dur="indefinite" restart="never" nodeType="tmRoot"/>
+      </p:par>
+    </p:tnLst>
+  </p:timing>
 </p:sld>
 </file>
 
@@ -11582,6 +11610,13 @@
   <p:clrMapOvr>
     <a:masterClrMapping/>
   </p:clrMapOvr>
+  <p:timing>
+    <p:tnLst>
+      <p:par>
+        <p:cTn id="1" dur="indefinite" restart="never" nodeType="tmRoot"/>
+      </p:par>
+    </p:tnLst>
+  </p:timing>
 </p:sld>
 </file>
 
@@ -12387,6 +12422,13 @@
   <p:clrMapOvr>
     <a:masterClrMapping/>
   </p:clrMapOvr>
+  <p:timing>
+    <p:tnLst>
+      <p:par>
+        <p:cTn id="1" dur="indefinite" restart="never" nodeType="tmRoot"/>
+      </p:par>
+    </p:tnLst>
+  </p:timing>
 </p:sld>
 </file>
 
@@ -13856,6 +13898,13 @@
   <p:clrMapOvr>
     <a:masterClrMapping/>
   </p:clrMapOvr>
+  <p:timing>
+    <p:tnLst>
+      <p:par>
+        <p:cTn id="1" dur="indefinite" restart="never" nodeType="tmRoot"/>
+      </p:par>
+    </p:tnLst>
+  </p:timing>
 </p:sld>
 </file>
 
@@ -14173,6 +14222,13 @@
   <p:clrMapOvr>
     <a:masterClrMapping/>
   </p:clrMapOvr>
+  <p:timing>
+    <p:tnLst>
+      <p:par>
+        <p:cTn id="1" dur="indefinite" restart="never" nodeType="tmRoot"/>
+      </p:par>
+    </p:tnLst>
+  </p:timing>
 </p:sld>
 </file>
 
@@ -14361,6 +14417,13 @@
   <p:clrMapOvr>
     <a:masterClrMapping/>
   </p:clrMapOvr>
+  <p:timing>
+    <p:tnLst>
+      <p:par>
+        <p:cTn id="1" dur="indefinite" restart="never" nodeType="tmRoot"/>
+      </p:par>
+    </p:tnLst>
+  </p:timing>
 </p:sld>
 </file>
 
@@ -14650,7 +14713,7 @@
         <p:spPr>
           <a:xfrm>
             <a:off x="718199" y="1926557"/>
-            <a:ext cx="1908000" cy="306000"/>
+            <a:ext cx="1908000" cy="400110"/>
           </a:xfrm>
           <a:prstGeom prst="rect">
             <a:avLst/>
@@ -14668,14 +14731,74 @@
           <a:p>
             <a:pPr algn="ctr"/>
             <a:r>
-              <a:rPr sz="1000" b="1">
+              <a:rPr sz="1000" b="1" dirty="0" err="1">
                 <a:solidFill>
                   <a:srgbClr val="FDF6EE"/>
                 </a:solidFill>
                 <a:latin typeface="Calibri"/>
               </a:rPr>
-              <a:t>Trần Văn Nam</a:t>
-            </a:r>
+              <a:t>Trần</a:t>
+            </a:r>
+            <a:r>
+              <a:rPr sz="1000" b="1" dirty="0">
+                <a:solidFill>
+                  <a:srgbClr val="FDF6EE"/>
+                </a:solidFill>
+                <a:latin typeface="Calibri"/>
+              </a:rPr>
+              <a:t> </a:t>
+            </a:r>
+            <a:r>
+              <a:rPr sz="1000" b="1" dirty="0" err="1">
+                <a:solidFill>
+                  <a:srgbClr val="FDF6EE"/>
+                </a:solidFill>
+                <a:latin typeface="Calibri"/>
+              </a:rPr>
+              <a:t>Văn</a:t>
+            </a:r>
+            <a:r>
+              <a:rPr sz="1000" b="1" dirty="0">
+                <a:solidFill>
+                  <a:srgbClr val="FDF6EE"/>
+                </a:solidFill>
+                <a:latin typeface="Calibri"/>
+              </a:rPr>
+              <a:t> </a:t>
+            </a:r>
+            <a:r>
+              <a:rPr sz="1000" b="1" dirty="0" smtClean="0">
+                <a:solidFill>
+                  <a:srgbClr val="FDF6EE"/>
+                </a:solidFill>
+                <a:latin typeface="Calibri"/>
+              </a:rPr>
+              <a:t>Nam</a:t>
+            </a:r>
+            <a:endParaRPr lang="en-US" sz="1000" b="1" dirty="0" smtClean="0">
+              <a:solidFill>
+                <a:srgbClr val="FDF6EE"/>
+              </a:solidFill>
+              <a:latin typeface="Calibri"/>
+            </a:endParaRPr>
+          </a:p>
+          <a:p>
+            <a:pPr algn="ctr"/>
+            <a:r>
+              <a:rPr lang="en-US" sz="1000" b="1" dirty="0" smtClean="0">
+                <a:solidFill>
+                  <a:srgbClr val="FDF6EE"/>
+                </a:solidFill>
+                <a:latin typeface="Calibri"/>
+              </a:rPr>
+              <a:t>2411110075</a:t>
+            </a:r>
+            <a:endParaRPr sz="1000" b="1" dirty="0">
+              <a:solidFill>
+                <a:srgbClr val="FDF6EE"/>
+              </a:solidFill>
+              <a:latin typeface="Calibri"/>
+            </a:endParaRPr>
           </a:p>
         </p:txBody>
       </p:sp>
@@ -14833,8 +14956,8 @@
         </p:nvSpPr>
         <p:spPr>
           <a:xfrm>
-            <a:off x="2903399" y="1926557"/>
-            <a:ext cx="1908000" cy="306000"/>
+            <a:off x="2948398" y="1901557"/>
+            <a:ext cx="1908000" cy="553998"/>
           </a:xfrm>
           <a:prstGeom prst="rect">
             <a:avLst/>
@@ -14852,14 +14975,67 @@
           <a:p>
             <a:pPr algn="ctr"/>
             <a:r>
-              <a:rPr sz="1000" b="1">
+              <a:rPr sz="1000" b="1" dirty="0">
                 <a:solidFill>
                   <a:srgbClr val="FDF6EE"/>
                 </a:solidFill>
                 <a:latin typeface="Calibri"/>
               </a:rPr>
-              <a:t>Phan Gia Bảo</a:t>
-            </a:r>
+              <a:t>Phan </a:t>
+            </a:r>
+            <a:r>
+              <a:rPr sz="1000" b="1" dirty="0" err="1">
+                <a:solidFill>
+                  <a:srgbClr val="FDF6EE"/>
+                </a:solidFill>
+                <a:latin typeface="Calibri"/>
+              </a:rPr>
+              <a:t>Gia</a:t>
+            </a:r>
+            <a:r>
+              <a:rPr sz="1000" b="1" dirty="0">
+                <a:solidFill>
+                  <a:srgbClr val="FDF6EE"/>
+                </a:solidFill>
+                <a:latin typeface="Calibri"/>
+              </a:rPr>
+              <a:t> </a:t>
+            </a:r>
+            <a:r>
+              <a:rPr sz="1000" b="1" dirty="0" err="1" smtClean="0">
+                <a:solidFill>
+                  <a:srgbClr val="FDF6EE"/>
+                </a:solidFill>
+                <a:latin typeface="Calibri"/>
+              </a:rPr>
+              <a:t>Bảo</a:t>
+            </a:r>
+            <a:endParaRPr lang="en-US" sz="1000" b="1" dirty="0" smtClean="0">
+              <a:solidFill>
+                <a:srgbClr val="FDF6EE"/>
+              </a:solidFill>
+              <a:latin typeface="Calibri"/>
+            </a:endParaRPr>
+          </a:p>
+          <a:p>
+            <a:pPr algn="ctr"/>
+            <a:r>
+              <a:rPr lang="en-US" sz="1000" b="1" dirty="0" smtClean="0">
+                <a:solidFill>
+                  <a:srgbClr val="FDF6EE"/>
+                </a:solidFill>
+              </a:rPr>
+              <a:t>2411110020</a:t>
+            </a:r>
+          </a:p>
+          <a:p>
+            <a:pPr algn="ctr"/>
+            <a:endParaRPr sz="1000" b="1" dirty="0">
+              <a:solidFill>
+                <a:srgbClr val="FDF6EE"/>
+              </a:solidFill>
+              <a:latin typeface="Calibri"/>
+            </a:endParaRPr>
           </a:p>
         </p:txBody>
       </p:sp>
@@ -15018,7 +15194,7 @@
         <p:spPr>
           <a:xfrm>
             <a:off x="5088599" y="1926557"/>
-            <a:ext cx="1908000" cy="246221"/>
+            <a:ext cx="1908000" cy="553998"/>
           </a:xfrm>
           <a:prstGeom prst="rect">
             <a:avLst/>
@@ -15036,32 +15212,85 @@
           <a:p>
             <a:pPr algn="ctr"/>
             <a:r>
-              <a:rPr sz="1000" b="1">
+              <a:rPr sz="1000" b="1" dirty="0" err="1">
                 <a:solidFill>
                   <a:srgbClr val="FDF6EE"/>
                 </a:solidFill>
                 <a:latin typeface="Calibri"/>
               </a:rPr>
-              <a:t>Lục Vĩn</a:t>
-            </a:r>
-            <a:r>
-              <a:rPr lang="en-US" sz="1000" b="1">
+              <a:t>Lục</a:t>
+            </a:r>
+            <a:r>
+              <a:rPr sz="1000" b="1" dirty="0">
                 <a:solidFill>
                   <a:srgbClr val="FDF6EE"/>
                 </a:solidFill>
                 <a:latin typeface="Calibri"/>
               </a:rPr>
+              <a:t> </a:t>
+            </a:r>
+            <a:r>
+              <a:rPr sz="1000" b="1" dirty="0" err="1">
+                <a:solidFill>
+                  <a:srgbClr val="FDF6EE"/>
+                </a:solidFill>
+                <a:latin typeface="Calibri"/>
+              </a:rPr>
+              <a:t>Vĩn</a:t>
+            </a:r>
+            <a:r>
+              <a:rPr lang="en-US" sz="1000" b="1" dirty="0" err="1">
+                <a:solidFill>
+                  <a:srgbClr val="FDF6EE"/>
+                </a:solidFill>
+                <a:latin typeface="Calibri"/>
+              </a:rPr>
               <a:t>h</a:t>
             </a:r>
             <a:r>
-              <a:rPr sz="1000" b="1">
+              <a:rPr sz="1000" b="1" dirty="0">
                 <a:solidFill>
                   <a:srgbClr val="FDF6EE"/>
                 </a:solidFill>
                 <a:latin typeface="Calibri"/>
               </a:rPr>
-              <a:t> Khang</a:t>
-            </a:r>
+              <a:t> </a:t>
+            </a:r>
+            <a:r>
+              <a:rPr sz="1000" b="1" dirty="0" err="1" smtClean="0">
+                <a:solidFill>
+                  <a:srgbClr val="FDF6EE"/>
+                </a:solidFill>
+                <a:latin typeface="Calibri"/>
+              </a:rPr>
+              <a:t>Khang</a:t>
+            </a:r>
+            <a:endParaRPr lang="en-US" sz="1000" b="1" dirty="0" smtClean="0">
+              <a:solidFill>
+                <a:srgbClr val="FDF6EE"/>
+              </a:solidFill>
+              <a:latin typeface="Calibri"/>
+            </a:endParaRPr>
+          </a:p>
+          <a:p>
+            <a:pPr algn="ctr"/>
+            <a:r>
+              <a:rPr lang="en-US" sz="1000" b="1" dirty="0" smtClean="0">
+                <a:solidFill>
+                  <a:srgbClr val="FDF6EE"/>
+                </a:solidFill>
+              </a:rPr>
+              <a:t>2411110092</a:t>
+            </a:r>
+          </a:p>
+          <a:p>
+            <a:pPr algn="ctr"/>
+            <a:endParaRPr sz="1000" b="1" dirty="0">
+              <a:solidFill>
+                <a:srgbClr val="FDF6EE"/>
+              </a:solidFill>
+              <a:latin typeface="Calibri"/>
+            </a:endParaRPr>
           </a:p>
         </p:txBody>
       </p:sp>
@@ -15220,7 +15449,7 @@
         <p:spPr>
           <a:xfrm>
             <a:off x="7273799" y="1926557"/>
-            <a:ext cx="1908000" cy="306000"/>
+            <a:ext cx="1908000" cy="400110"/>
           </a:xfrm>
           <a:prstGeom prst="rect">
             <a:avLst/>
@@ -15238,14 +15467,91 @@
           <a:p>
             <a:pPr algn="ctr"/>
             <a:r>
-              <a:rPr sz="1000" b="1">
+              <a:rPr sz="1000" b="1" dirty="0" err="1">
                 <a:solidFill>
                   <a:srgbClr val="FDF6EE"/>
                 </a:solidFill>
                 <a:latin typeface="Calibri"/>
               </a:rPr>
-              <a:t>Nguyễn Kha Gia Hào</a:t>
-            </a:r>
+              <a:t>Nguyễn</a:t>
+            </a:r>
+            <a:r>
+              <a:rPr sz="1000" b="1" dirty="0">
+                <a:solidFill>
+                  <a:srgbClr val="FDF6EE"/>
+                </a:solidFill>
+                <a:latin typeface="Calibri"/>
+              </a:rPr>
+              <a:t> </a:t>
+            </a:r>
+            <a:r>
+              <a:rPr sz="1000" b="1" dirty="0" err="1">
+                <a:solidFill>
+                  <a:srgbClr val="FDF6EE"/>
+                </a:solidFill>
+                <a:latin typeface="Calibri"/>
+              </a:rPr>
+              <a:t>Kha</a:t>
+            </a:r>
+            <a:r>
+              <a:rPr sz="1000" b="1" dirty="0">
+                <a:solidFill>
+                  <a:srgbClr val="FDF6EE"/>
+                </a:solidFill>
+                <a:latin typeface="Calibri"/>
+              </a:rPr>
+              <a:t> </a:t>
+            </a:r>
+            <a:r>
+              <a:rPr sz="1000" b="1" dirty="0" err="1">
+                <a:solidFill>
+                  <a:srgbClr val="FDF6EE"/>
+                </a:solidFill>
+                <a:latin typeface="Calibri"/>
+              </a:rPr>
+              <a:t>Gia</a:t>
+            </a:r>
+            <a:r>
+              <a:rPr sz="1000" b="1" dirty="0">
+                <a:solidFill>
+                  <a:srgbClr val="FDF6EE"/>
+                </a:solidFill>
+                <a:latin typeface="Calibri"/>
+              </a:rPr>
+              <a:t> </a:t>
+            </a:r>
+            <a:r>
+              <a:rPr sz="1000" b="1" dirty="0" err="1" smtClean="0">
+                <a:solidFill>
+                  <a:srgbClr val="FDF6EE"/>
+                </a:solidFill>
+                <a:latin typeface="Calibri"/>
+              </a:rPr>
+              <a:t>Hào</a:t>
+            </a:r>
+            <a:endParaRPr lang="en-US" sz="1000" b="1" dirty="0" smtClean="0">
+              <a:solidFill>
+                <a:srgbClr val="FDF6EE"/>
+              </a:solidFill>
+              <a:latin typeface="Calibri"/>
+            </a:endParaRPr>
+          </a:p>
+          <a:p>
+            <a:pPr algn="ctr"/>
+            <a:r>
+              <a:rPr lang="en-US" sz="1000" b="1" dirty="0" smtClean="0">
+                <a:solidFill>
+                  <a:srgbClr val="FDF6EE"/>
+                </a:solidFill>
+              </a:rPr>
+              <a:t>2411110087</a:t>
+            </a:r>
+            <a:endParaRPr sz="1000" b="1" dirty="0">
+              <a:solidFill>
+                <a:srgbClr val="FDF6EE"/>
+              </a:solidFill>
+              <a:latin typeface="Calibri"/>
+            </a:endParaRPr>
           </a:p>
         </p:txBody>
       </p:sp>
@@ -15404,7 +15710,7 @@
         <p:spPr>
           <a:xfrm>
             <a:off x="9458999" y="1926557"/>
-            <a:ext cx="1908000" cy="306000"/>
+            <a:ext cx="1908000" cy="400110"/>
           </a:xfrm>
           <a:prstGeom prst="rect">
             <a:avLst/>
@@ -15422,13 +15728,48 @@
           <a:p>
             <a:pPr algn="ctr"/>
             <a:r>
-              <a:rPr sz="1000" b="1">
+              <a:rPr sz="1000" b="1" dirty="0" err="1" smtClean="0">
                 <a:solidFill>
                   <a:srgbClr val="FDF6EE"/>
                 </a:solidFill>
                 <a:latin typeface="Calibri"/>
               </a:rPr>
-              <a:t>Huỳnh Khánh</a:t>
+              <a:t>Huỳnh</a:t>
+            </a:r>
+            <a:r>
+              <a:rPr sz="1000" b="1" dirty="0" smtClean="0">
+                <a:solidFill>
+                  <a:srgbClr val="FDF6EE"/>
+                </a:solidFill>
+                <a:latin typeface="Calibri"/>
+              </a:rPr>
+              <a:t> </a:t>
+            </a:r>
+            <a:r>
+              <a:rPr sz="1000" b="1" dirty="0" err="1" smtClean="0">
+                <a:solidFill>
+                  <a:srgbClr val="FDF6EE"/>
+                </a:solidFill>
+                <a:latin typeface="Calibri"/>
+              </a:rPr>
+              <a:t>Khánh</a:t>
+            </a:r>
+            <a:endParaRPr lang="en-US" sz="1000" b="1" dirty="0" smtClean="0">
+              <a:solidFill>
+                <a:srgbClr val="FDF6EE"/>
+              </a:solidFill>
+              <a:latin typeface="Calibri"/>
+            </a:endParaRPr>
+          </a:p>
+          <a:p>
+            <a:pPr algn="ctr"/>
+            <a:r>
+              <a:rPr lang="en-US" sz="1000" b="1" dirty="0" smtClean="0">
+                <a:solidFill>
+                  <a:srgbClr val="FDF6EE"/>
+                </a:solidFill>
+              </a:rPr>
+              <a:t>2411110084</a:t>
             </a:r>
           </a:p>
         </p:txBody>
@@ -15487,6 +15828,13 @@
   <p:clrMapOvr>
     <a:masterClrMapping/>
   </p:clrMapOvr>
+  <p:timing>
+    <p:tnLst>
+      <p:par>
+        <p:cTn id="1" dur="indefinite" restart="never" nodeType="tmRoot"/>
+      </p:par>
+    </p:tnLst>
+  </p:timing>
 </p:sld>
 </file>
 
@@ -17110,6 +17458,13 @@
   <p:clrMapOvr>
     <a:masterClrMapping/>
   </p:clrMapOvr>
+  <p:timing>
+    <p:tnLst>
+      <p:par>
+        <p:cTn id="1" dur="indefinite" restart="never" nodeType="tmRoot"/>
+      </p:par>
+    </p:tnLst>
+  </p:timing>
 </p:sld>
 </file>
 
@@ -17787,6 +18142,13 @@
   <p:clrMapOvr>
     <a:masterClrMapping/>
   </p:clrMapOvr>
+  <p:timing>
+    <p:tnLst>
+      <p:par>
+        <p:cTn id="1" dur="indefinite" restart="never" nodeType="tmRoot"/>
+      </p:par>
+    </p:tnLst>
+  </p:timing>
 </p:sld>
 </file>
 
@@ -19860,6 +20222,13 @@
   <p:clrMapOvr>
     <a:masterClrMapping/>
   </p:clrMapOvr>
+  <p:timing>
+    <p:tnLst>
+      <p:par>
+        <p:cTn id="1" dur="indefinite" restart="never" nodeType="tmRoot"/>
+      </p:par>
+    </p:tnLst>
+  </p:timing>
 </p:sld>
 </file>
 
@@ -22811,6 +23180,13 @@
   <p:clrMapOvr>
     <a:masterClrMapping/>
   </p:clrMapOvr>
+  <p:timing>
+    <p:tnLst>
+      <p:par>
+        <p:cTn id="1" dur="indefinite" restart="never" nodeType="tmRoot"/>
+      </p:par>
+    </p:tnLst>
+  </p:timing>
 </p:sld>
 </file>
 
@@ -23938,6 +24314,13 @@
   <p:clrMapOvr>
     <a:masterClrMapping/>
   </p:clrMapOvr>
+  <p:timing>
+    <p:tnLst>
+      <p:par>
+        <p:cTn id="1" dur="indefinite" restart="never" nodeType="tmRoot"/>
+      </p:par>
+    </p:tnLst>
+  </p:timing>
 </p:sld>
 </file>
 
@@ -25412,6 +25795,13 @@
   <p:clrMapOvr>
     <a:masterClrMapping/>
   </p:clrMapOvr>
+  <p:timing>
+    <p:tnLst>
+      <p:par>
+        <p:cTn id="1" dur="indefinite" restart="never" nodeType="tmRoot"/>
+      </p:par>
+    </p:tnLst>
+  </p:timing>
 </p:sld>
 </file>
 
@@ -26687,6 +27077,13 @@
   <p:clrMapOvr>
     <a:masterClrMapping/>
   </p:clrMapOvr>
+  <p:timing>
+    <p:tnLst>
+      <p:par>
+        <p:cTn id="1" dur="indefinite" restart="never" nodeType="tmRoot"/>
+      </p:par>
+    </p:tnLst>
+  </p:timing>
 </p:sld>
 </file>
 

</xml_diff>